<commit_message>
lots of work: move all trivy stuff to trivy channel finished elecotron build for windows infinite work with UI/UX/css add mangnify user customization magnify drag & resize running like a charm magnify contentexternla customization added trivy channel to magnify trivy channel refactoring complete icons svg->typescript (remove external deps)
</commit_message>
<xml_diff>
--- a/front/media/niklaus-wirth.pptx
+++ b/front/media/niklaus-wirth.pptx
@@ -9,6 +9,7 @@
     <p:sldId id="257" r:id="rId3"/>
     <p:sldId id="258" r:id="rId4"/>
     <p:sldId id="261" r:id="rId5"/>
+    <p:sldId id="262" r:id="rId6"/>
   </p:sldIdLst>
   <p:sldSz cx="12192000" cy="6858000"/>
   <p:notesSz cx="6858000" cy="9144000"/>
@@ -107,6 +108,11 @@
       </a:defRPr>
     </a:lvl9pPr>
   </p:defaultTextStyle>
+  <p:extLst>
+    <p:ext uri="{EFAFB233-063F-42B5-8137-9DF3F51BA10A}">
+      <p15:sldGuideLst xmlns:p15="http://schemas.microsoft.com/office/powerpoint/2012/main"/>
+    </p:ext>
+  </p:extLst>
 </p:presentation>
 </file>
 
@@ -259,7 +265,7 @@
           <a:p>
             <a:fld id="{5615BFE4-3E82-429A-A766-8166449B0D87}" type="datetimeFigureOut">
               <a:rPr lang="es-ES" smtClean="0"/>
-              <a:t>09/06/2024</a:t>
+              <a:t>13/03/2026</a:t>
             </a:fld>
             <a:endParaRPr lang="es-ES"/>
           </a:p>
@@ -459,7 +465,7 @@
           <a:p>
             <a:fld id="{5615BFE4-3E82-429A-A766-8166449B0D87}" type="datetimeFigureOut">
               <a:rPr lang="es-ES" smtClean="0"/>
-              <a:t>09/06/2024</a:t>
+              <a:t>13/03/2026</a:t>
             </a:fld>
             <a:endParaRPr lang="es-ES"/>
           </a:p>
@@ -669,7 +675,7 @@
           <a:p>
             <a:fld id="{5615BFE4-3E82-429A-A766-8166449B0D87}" type="datetimeFigureOut">
               <a:rPr lang="es-ES" smtClean="0"/>
-              <a:t>09/06/2024</a:t>
+              <a:t>13/03/2026</a:t>
             </a:fld>
             <a:endParaRPr lang="es-ES"/>
           </a:p>
@@ -869,7 +875,7 @@
           <a:p>
             <a:fld id="{5615BFE4-3E82-429A-A766-8166449B0D87}" type="datetimeFigureOut">
               <a:rPr lang="es-ES" smtClean="0"/>
-              <a:t>09/06/2024</a:t>
+              <a:t>13/03/2026</a:t>
             </a:fld>
             <a:endParaRPr lang="es-ES"/>
           </a:p>
@@ -1145,7 +1151,7 @@
           <a:p>
             <a:fld id="{5615BFE4-3E82-429A-A766-8166449B0D87}" type="datetimeFigureOut">
               <a:rPr lang="es-ES" smtClean="0"/>
-              <a:t>09/06/2024</a:t>
+              <a:t>13/03/2026</a:t>
             </a:fld>
             <a:endParaRPr lang="es-ES"/>
           </a:p>
@@ -1413,7 +1419,7 @@
           <a:p>
             <a:fld id="{5615BFE4-3E82-429A-A766-8166449B0D87}" type="datetimeFigureOut">
               <a:rPr lang="es-ES" smtClean="0"/>
-              <a:t>09/06/2024</a:t>
+              <a:t>13/03/2026</a:t>
             </a:fld>
             <a:endParaRPr lang="es-ES"/>
           </a:p>
@@ -1828,7 +1834,7 @@
           <a:p>
             <a:fld id="{5615BFE4-3E82-429A-A766-8166449B0D87}" type="datetimeFigureOut">
               <a:rPr lang="es-ES" smtClean="0"/>
-              <a:t>09/06/2024</a:t>
+              <a:t>13/03/2026</a:t>
             </a:fld>
             <a:endParaRPr lang="es-ES"/>
           </a:p>
@@ -1970,7 +1976,7 @@
           <a:p>
             <a:fld id="{5615BFE4-3E82-429A-A766-8166449B0D87}" type="datetimeFigureOut">
               <a:rPr lang="es-ES" smtClean="0"/>
-              <a:t>09/06/2024</a:t>
+              <a:t>13/03/2026</a:t>
             </a:fld>
             <a:endParaRPr lang="es-ES"/>
           </a:p>
@@ -2083,7 +2089,7 @@
           <a:p>
             <a:fld id="{5615BFE4-3E82-429A-A766-8166449B0D87}" type="datetimeFigureOut">
               <a:rPr lang="es-ES" smtClean="0"/>
-              <a:t>09/06/2024</a:t>
+              <a:t>13/03/2026</a:t>
             </a:fld>
             <a:endParaRPr lang="es-ES"/>
           </a:p>
@@ -2396,7 +2402,7 @@
           <a:p>
             <a:fld id="{5615BFE4-3E82-429A-A766-8166449B0D87}" type="datetimeFigureOut">
               <a:rPr lang="es-ES" smtClean="0"/>
-              <a:t>09/06/2024</a:t>
+              <a:t>13/03/2026</a:t>
             </a:fld>
             <a:endParaRPr lang="es-ES"/>
           </a:p>
@@ -2685,7 +2691,7 @@
           <a:p>
             <a:fld id="{5615BFE4-3E82-429A-A766-8166449B0D87}" type="datetimeFigureOut">
               <a:rPr lang="es-ES" smtClean="0"/>
-              <a:t>09/06/2024</a:t>
+              <a:t>13/03/2026</a:t>
             </a:fld>
             <a:endParaRPr lang="es-ES"/>
           </a:p>
@@ -2928,7 +2934,7 @@
           <a:p>
             <a:fld id="{5615BFE4-3E82-429A-A766-8166449B0D87}" type="datetimeFigureOut">
               <a:rPr lang="es-ES" smtClean="0"/>
-              <a:t>09/06/2024</a:t>
+              <a:t>13/03/2026</a:t>
             </a:fld>
             <a:endParaRPr lang="es-ES"/>
           </a:p>
@@ -3690,6 +3696,124 @@
 </p:sld>
 </file>
 
+<file path=ppt/slides/slide5.xml><?xml version="1.0" encoding="utf-8"?>
+<p:sld xmlns:a="http://schemas.openxmlformats.org/drawingml/2006/main" xmlns:r="http://schemas.openxmlformats.org/officeDocument/2006/relationships" xmlns:p="http://schemas.openxmlformats.org/presentationml/2006/main">
+  <p:cSld>
+    <p:spTree>
+      <p:nvGrpSpPr>
+        <p:cNvPr id="1" name="">
+          <a:extLst>
+            <a:ext uri="{FF2B5EF4-FFF2-40B4-BE49-F238E27FC236}">
+              <a16:creationId xmlns:a16="http://schemas.microsoft.com/office/drawing/2014/main" id="{AC6E2E7C-7767-C5D3-6BD3-9F859F1FE86B}"/>
+            </a:ext>
+          </a:extLst>
+        </p:cNvPr>
+        <p:cNvGrpSpPr/>
+        <p:nvPr/>
+      </p:nvGrpSpPr>
+      <p:grpSpPr>
+        <a:xfrm>
+          <a:off x="0" y="0"/>
+          <a:ext cx="0" cy="0"/>
+          <a:chOff x="0" y="0"/>
+          <a:chExt cx="0" cy="0"/>
+        </a:xfrm>
+      </p:grpSpPr>
+      <p:pic>
+        <p:nvPicPr>
+          <p:cNvPr id="3" name="Picture 2">
+            <a:extLst>
+              <a:ext uri="{FF2B5EF4-FFF2-40B4-BE49-F238E27FC236}">
+                <a16:creationId xmlns:a16="http://schemas.microsoft.com/office/drawing/2014/main" id="{F6191265-4DAF-8C70-AA23-C0B957A9567C}"/>
+              </a:ext>
+            </a:extLst>
+          </p:cNvPr>
+          <p:cNvPicPr>
+            <a:picLocks noChangeAspect="1"/>
+          </p:cNvPicPr>
+          <p:nvPr/>
+        </p:nvPicPr>
+        <p:blipFill rotWithShape="1">
+          <a:blip r:embed="rId2">
+            <a:clrChange>
+              <a:clrFrom>
+                <a:srgbClr val="54544C"/>
+              </a:clrFrom>
+              <a:clrTo>
+                <a:srgbClr val="54544C">
+                  <a:alpha val="0"/>
+                </a:srgbClr>
+              </a:clrTo>
+            </a:clrChange>
+          </a:blip>
+          <a:srcRect l="28895" t="7232" r="30847" b="4333"/>
+          <a:stretch/>
+        </p:blipFill>
+        <p:spPr>
+          <a:xfrm>
+            <a:off x="4767089" y="1787525"/>
+            <a:ext cx="2287761" cy="2825750"/>
+          </a:xfrm>
+          <a:prstGeom prst="rect">
+            <a:avLst/>
+          </a:prstGeom>
+        </p:spPr>
+      </p:pic>
+      <p:sp>
+        <p:nvSpPr>
+          <p:cNvPr id="4" name="TextBox 3">
+            <a:extLst>
+              <a:ext uri="{FF2B5EF4-FFF2-40B4-BE49-F238E27FC236}">
+                <a16:creationId xmlns:a16="http://schemas.microsoft.com/office/drawing/2014/main" id="{E7CFE6B9-BB2B-A7C0-59D3-E62ECC248079}"/>
+              </a:ext>
+            </a:extLst>
+          </p:cNvPr>
+          <p:cNvSpPr txBox="1"/>
+          <p:nvPr/>
+        </p:nvSpPr>
+        <p:spPr>
+          <a:xfrm>
+            <a:off x="4450357" y="3688461"/>
+            <a:ext cx="3291286" cy="1200329"/>
+          </a:xfrm>
+          <a:prstGeom prst="rect">
+            <a:avLst/>
+          </a:prstGeom>
+          <a:noFill/>
+        </p:spPr>
+        <p:txBody>
+          <a:bodyPr wrap="none" rtlCol="0">
+            <a:spAutoFit/>
+          </a:bodyPr>
+          <a:lstStyle/>
+          <a:p>
+            <a:r>
+              <a:rPr lang="es-ES" sz="7200" dirty="0" err="1">
+                <a:latin typeface="Lucida Fax" panose="02060602050505020204" pitchFamily="18" charset="0"/>
+                <a:cs typeface="Aharoni" panose="02010803020104030203" pitchFamily="2" charset="-79"/>
+              </a:rPr>
+              <a:t>Kwirth</a:t>
+            </a:r>
+            <a:endParaRPr lang="es-ES" sz="7200" dirty="0">
+              <a:latin typeface="Lucida Fax" panose="02060602050505020204" pitchFamily="18" charset="0"/>
+              <a:cs typeface="Aharoni" panose="02010803020104030203" pitchFamily="2" charset="-79"/>
+            </a:endParaRPr>
+          </a:p>
+        </p:txBody>
+      </p:sp>
+    </p:spTree>
+    <p:extLst>
+      <p:ext uri="{BB962C8B-B14F-4D97-AF65-F5344CB8AC3E}">
+        <p14:creationId xmlns:p14="http://schemas.microsoft.com/office/powerpoint/2010/main" val="559484278"/>
+      </p:ext>
+    </p:extLst>
+  </p:cSld>
+  <p:clrMapOvr>
+    <a:masterClrMapping/>
+  </p:clrMapOvr>
+</p:sld>
+</file>
+
 <file path=ppt/theme/theme1.xml><?xml version="1.0" encoding="utf-8"?>
 <a:theme xmlns:a="http://schemas.openxmlformats.org/drawingml/2006/main" name="Office Theme">
   <a:themeElements>

</xml_diff>